<commit_message>
updates some of the slides
</commit_message>
<xml_diff>
--- a/docs/data/timeseries/Model adequacy.pptx
+++ b/docs/data/timeseries/Model adequacy.pptx
@@ -5,7 +5,7 @@
     <p:sldMasterId id="2147483648" r:id="rId1"/>
   </p:sldMasterIdLst>
   <p:notesMasterIdLst>
-    <p:notesMasterId r:id="rId16"/>
+    <p:notesMasterId r:id="rId17"/>
   </p:notesMasterIdLst>
   <p:sldIdLst>
     <p:sldId id="256" r:id="rId2"/>
@@ -17,11 +17,12 @@
     <p:sldId id="262" r:id="rId8"/>
     <p:sldId id="263" r:id="rId9"/>
     <p:sldId id="264" r:id="rId10"/>
-    <p:sldId id="265" r:id="rId11"/>
-    <p:sldId id="266" r:id="rId12"/>
-    <p:sldId id="267" r:id="rId13"/>
-    <p:sldId id="268" r:id="rId14"/>
-    <p:sldId id="272" r:id="rId15"/>
+    <p:sldId id="273" r:id="rId11"/>
+    <p:sldId id="265" r:id="rId12"/>
+    <p:sldId id="266" r:id="rId13"/>
+    <p:sldId id="267" r:id="rId14"/>
+    <p:sldId id="268" r:id="rId15"/>
+    <p:sldId id="272" r:id="rId16"/>
   </p:sldIdLst>
   <p:sldSz cx="12192000" cy="6858000"/>
   <p:notesSz cx="6858000" cy="12192000"/>
@@ -342,7 +343,13 @@
   <p:cSld>
     <p:spTree>
       <p:nvGrpSpPr>
-        <p:cNvPr id="1" name=""/>
+        <p:cNvPr id="1" name="">
+          <a:extLst>
+            <a:ext uri="{FF2B5EF4-FFF2-40B4-BE49-F238E27FC236}">
+              <a16:creationId xmlns:a16="http://schemas.microsoft.com/office/drawing/2014/main" id="{F575562A-910E-E093-C979-09917C9F4026}"/>
+            </a:ext>
+          </a:extLst>
+        </p:cNvPr>
         <p:cNvGrpSpPr/>
         <p:nvPr/>
       </p:nvGrpSpPr>
@@ -356,7 +363,13 @@
       </p:grpSpPr>
       <p:sp>
         <p:nvSpPr>
-          <p:cNvPr id="2" name="Slide Image Placeholder 1"/>
+          <p:cNvPr id="2" name="Slide Image Placeholder 1">
+            <a:extLst>
+              <a:ext uri="{FF2B5EF4-FFF2-40B4-BE49-F238E27FC236}">
+                <a16:creationId xmlns:a16="http://schemas.microsoft.com/office/drawing/2014/main" id="{EB1F3D4B-9764-B6B0-D769-BB015DA8E6D3}"/>
+              </a:ext>
+            </a:extLst>
+          </p:cNvPr>
           <p:cNvSpPr>
             <a:spLocks noGrp="1" noRot="1" noChangeAspect="1"/>
           </p:cNvSpPr>
@@ -368,7 +381,13 @@
       </p:sp>
       <p:sp>
         <p:nvSpPr>
-          <p:cNvPr id="3" name="Notes Placeholder 2"/>
+          <p:cNvPr id="3" name="Notes Placeholder 2">
+            <a:extLst>
+              <a:ext uri="{FF2B5EF4-FFF2-40B4-BE49-F238E27FC236}">
+                <a16:creationId xmlns:a16="http://schemas.microsoft.com/office/drawing/2014/main" id="{FA64E5ED-C6B1-A327-D7B2-8FAEA5A4B037}"/>
+              </a:ext>
+            </a:extLst>
+          </p:cNvPr>
           <p:cNvSpPr>
             <a:spLocks noGrp="1"/>
           </p:cNvSpPr>
@@ -383,14 +402,20 @@
           <a:p>
             <a:r>
               <a:rPr lang="en-US" dirty="0"/>
-              <a:t>Left: are the plus and minus residuals in random order? Observed 44 runs; the model produces 32-49. Passes. Right: does the spread grow with shoe size? Observed slope 0.63; the model essentially never produces anything above 0.23. Fails badly. Say the consequence out loud: the single residual SD of 5.7 cm we would have reported describes nobody — far too wide for size 36, far too narrow for size 47. Failing one test is enough.</a:t>
-            </a:r>
-          </a:p>
-        </p:txBody>
-      </p:sp>
-      <p:sp>
-        <p:nvSpPr>
-          <p:cNvPr id="4" name="Slide Number Placeholder 3"/>
+              <a:t>Let them look for 20-30 seconds before saying anything. Some will spot it, some will not — that is the point: eyeballing works sometimes but is unreliable, which is why we turn the comparison into a number.</a:t>
+            </a:r>
+          </a:p>
+        </p:txBody>
+      </p:sp>
+      <p:sp>
+        <p:nvSpPr>
+          <p:cNvPr id="4" name="Slide Number Placeholder 3">
+            <a:extLst>
+              <a:ext uri="{FF2B5EF4-FFF2-40B4-BE49-F238E27FC236}">
+                <a16:creationId xmlns:a16="http://schemas.microsoft.com/office/drawing/2014/main" id="{668C7688-1111-6BB3-9F05-DC953C191AF6}"/>
+              </a:ext>
+            </a:extLst>
+          </p:cNvPr>
           <p:cNvSpPr>
             <a:spLocks noGrp="1"/>
           </p:cNvSpPr>
@@ -414,7 +439,7 @@
     </p:spTree>
     <p:extLst>
       <p:ext uri="{BB962C8B-B14F-4D97-AF65-F5344CB8AC3E}">
-        <p14:creationId xmlns:p14="http://schemas.microsoft.com/office/powerpoint/2010/main" val="1024086991"/>
+        <p14:creationId xmlns:p14="http://schemas.microsoft.com/office/powerpoint/2010/main" val="2142019553"/>
       </p:ext>
     </p:extLst>
   </p:cSld>
@@ -470,7 +495,7 @@
           <a:p>
             <a:r>
               <a:rPr lang="en-US" dirty="0"/>
-              <a:t>Same logic, same problem, different data.</a:t>
+              <a:t>Left: are the plus and minus residuals in random order? Observed 44 runs; the model produces 32-49. Passes. Right: does the spread grow with shoe size? Observed slope 0.63; the model essentially never produces anything above 0.23. Fails badly. Say the consequence out loud: the single residual SD of 5.7 cm we would have reported describes nobody — far too wide for size 36, far too narrow for size 47. Failing one test is enough.</a:t>
             </a:r>
           </a:p>
         </p:txBody>
@@ -557,7 +582,7 @@
           <a:p>
             <a:r>
               <a:rPr lang="en-US" dirty="0"/>
-              <a:t>Keep this short. Palaeontologists face the identical situation: three candidate models, an AICc ranking, and parameters — rates of evolution — that people then interpret biologically. Those rate estimates are only meaningful if the model actually describes the trait dynamics.</a:t>
+              <a:t>Same logic, same problem, different data.</a:t>
             </a:r>
           </a:p>
         </p:txBody>
@@ -644,7 +669,7 @@
           <a:p>
             <a:r>
               <a:rPr lang="en-US" dirty="0"/>
-              <a:t>Do not dwell on the maths. What matters is that each statistic captures a feature the model has a commitment to, and each is compared against 1000 simulations exactly as in the shoe-size example. The net evolution test is the one that encodes the verbal definition of stasis: little net change.</a:t>
+              <a:t>Keep this short. Palaeontologists face the identical situation: three candidate models, an AICc ranking, and parameters — rates of evolution — that people then interpret biologically. Those rate estimates are only meaningful if the model actually describes the trait dynamics.</a:t>
             </a:r>
           </a:p>
         </p:txBody>
@@ -731,7 +756,7 @@
           <a:p>
             <a:r>
               <a:rPr lang="en-US" dirty="0"/>
-              <a:t>Close on point 5. Model adequacy is not a gatekeeping ritual: it tells you which assumptions your data break, and you decide whether that matters for the inference you want to make. An adequate model is also not a true model — it only means the data do not violate the specific properties you tested.</a:t>
+              <a:t>Do not dwell on the maths. What matters is that each statistic captures a feature the model has a commitment to, and each is compared against 1000 simulations exactly as in the shoe-size example. The net evolution test is the one that encodes the verbal definition of stasis: little net change.</a:t>
             </a:r>
           </a:p>
         </p:txBody>
@@ -754,6 +779,93 @@
             <a:fld id="{F7021451-1387-4CA6-816F-3879F97B5CBC}" type="slidenum">
               <a:rPr lang="en-US"/>
               <a:t>14</a:t>
+            </a:fld>
+            <a:endParaRPr lang="en-US"/>
+          </a:p>
+        </p:txBody>
+      </p:sp>
+    </p:spTree>
+    <p:extLst>
+      <p:ext uri="{BB962C8B-B14F-4D97-AF65-F5344CB8AC3E}">
+        <p14:creationId xmlns:p14="http://schemas.microsoft.com/office/powerpoint/2010/main" val="1024086991"/>
+      </p:ext>
+    </p:extLst>
+  </p:cSld>
+  <p:clrMapOvr>
+    <a:masterClrMapping/>
+  </p:clrMapOvr>
+</p:notes>
+</file>
+
+<file path=ppt/notesSlides/notesSlide15.xml><?xml version="1.0" encoding="utf-8"?>
+<p:notes xmlns:a="http://schemas.openxmlformats.org/drawingml/2006/main" xmlns:r="http://schemas.openxmlformats.org/officeDocument/2006/relationships" xmlns:p="http://schemas.openxmlformats.org/presentationml/2006/main">
+  <p:cSld>
+    <p:spTree>
+      <p:nvGrpSpPr>
+        <p:cNvPr id="1" name=""/>
+        <p:cNvGrpSpPr/>
+        <p:nvPr/>
+      </p:nvGrpSpPr>
+      <p:grpSpPr>
+        <a:xfrm>
+          <a:off x="0" y="0"/>
+          <a:ext cx="0" cy="0"/>
+          <a:chOff x="0" y="0"/>
+          <a:chExt cx="0" cy="0"/>
+        </a:xfrm>
+      </p:grpSpPr>
+      <p:sp>
+        <p:nvSpPr>
+          <p:cNvPr id="2" name="Slide Image Placeholder 1"/>
+          <p:cNvSpPr>
+            <a:spLocks noGrp="1" noRot="1" noChangeAspect="1"/>
+          </p:cNvSpPr>
+          <p:nvPr>
+            <p:ph type="sldImg"/>
+          </p:nvPr>
+        </p:nvSpPr>
+        <p:spPr/>
+      </p:sp>
+      <p:sp>
+        <p:nvSpPr>
+          <p:cNvPr id="3" name="Notes Placeholder 2"/>
+          <p:cNvSpPr>
+            <a:spLocks noGrp="1"/>
+          </p:cNvSpPr>
+          <p:nvPr>
+            <p:ph type="body" idx="1"/>
+          </p:nvPr>
+        </p:nvSpPr>
+        <p:spPr/>
+        <p:txBody>
+          <a:bodyPr/>
+          <a:lstStyle/>
+          <a:p>
+            <a:r>
+              <a:rPr lang="en-US" dirty="0"/>
+              <a:t>Close on point 5. Model adequacy is not a gatekeeping ritual: it tells you which assumptions your data break, and you decide whether that matters for the inference you want to make. An adequate model is also not a true model — it only means the data do not violate the specific properties you tested.</a:t>
+            </a:r>
+          </a:p>
+        </p:txBody>
+      </p:sp>
+      <p:sp>
+        <p:nvSpPr>
+          <p:cNvPr id="4" name="Slide Number Placeholder 3"/>
+          <p:cNvSpPr>
+            <a:spLocks noGrp="1"/>
+          </p:cNvSpPr>
+          <p:nvPr>
+            <p:ph type="sldNum" sz="quarter" idx="10"/>
+          </p:nvPr>
+        </p:nvSpPr>
+        <p:spPr/>
+        <p:txBody>
+          <a:bodyPr/>
+          <a:lstStyle/>
+          <a:p>
+            <a:fld id="{F7021451-1387-4CA6-816F-3879F97B5CBC}" type="slidenum">
+              <a:rPr lang="en-US"/>
+              <a:t>15</a:t>
             </a:fld>
             <a:endParaRPr lang="en-US"/>
           </a:p>
@@ -1898,6 +2010,258 @@
 
 <file path=ppt/slides/slide10.xml><?xml version="1.0" encoding="utf-8"?>
 <p:sld xmlns:a="http://schemas.openxmlformats.org/drawingml/2006/main" xmlns:r="http://schemas.openxmlformats.org/officeDocument/2006/relationships" xmlns:p="http://schemas.openxmlformats.org/presentationml/2006/main">
+  <p:cSld>
+    <p:spTree>
+      <p:nvGrpSpPr>
+        <p:cNvPr id="1" name="">
+          <a:extLst>
+            <a:ext uri="{FF2B5EF4-FFF2-40B4-BE49-F238E27FC236}">
+              <a16:creationId xmlns:a16="http://schemas.microsoft.com/office/drawing/2014/main" id="{D8AD5936-300E-0CA2-559E-B136AD99DFF7}"/>
+            </a:ext>
+          </a:extLst>
+        </p:cNvPr>
+        <p:cNvGrpSpPr/>
+        <p:nvPr/>
+      </p:nvGrpSpPr>
+      <p:grpSpPr>
+        <a:xfrm>
+          <a:off x="0" y="0"/>
+          <a:ext cx="0" cy="0"/>
+          <a:chOff x="0" y="0"/>
+          <a:chExt cx="0" cy="0"/>
+        </a:xfrm>
+      </p:grpSpPr>
+      <p:sp>
+        <p:nvSpPr>
+          <p:cNvPr id="2" name="Text 0">
+            <a:extLst>
+              <a:ext uri="{FF2B5EF4-FFF2-40B4-BE49-F238E27FC236}">
+                <a16:creationId xmlns:a16="http://schemas.microsoft.com/office/drawing/2014/main" id="{AD685E17-0054-2C40-6246-EB5AA09DFC88}"/>
+              </a:ext>
+            </a:extLst>
+          </p:cNvPr>
+          <p:cNvSpPr/>
+          <p:nvPr/>
+        </p:nvSpPr>
+        <p:spPr>
+          <a:xfrm>
+            <a:off x="566928" y="201168"/>
+            <a:ext cx="11055096" cy="777240"/>
+          </a:xfrm>
+          <a:prstGeom prst="rect">
+            <a:avLst/>
+          </a:prstGeom>
+          <a:noFill/>
+          <a:ln/>
+        </p:spPr>
+        <p:txBody>
+          <a:bodyPr wrap="square" lIns="0" tIns="0" rIns="0" bIns="0" rtlCol="0" anchor="t"/>
+          <a:lstStyle/>
+          <a:p>
+            <a:pPr marL="0" indent="0">
+              <a:buNone/>
+            </a:pPr>
+            <a:r>
+              <a:rPr lang="en-US" sz="3200" dirty="0">
+                <a:solidFill>
+                  <a:srgbClr val="000000"/>
+                </a:solidFill>
+                <a:latin typeface="Palatino" pitchFamily="34" charset="0"/>
+                <a:ea typeface="Palatino" pitchFamily="34" charset="-122"/>
+                <a:cs typeface="Palatino" pitchFamily="34" charset="-120"/>
+              </a:rPr>
+              <a:t>Let the winning model make some data</a:t>
+            </a:r>
+            <a:endParaRPr lang="en-US" sz="3200" dirty="0"/>
+          </a:p>
+        </p:txBody>
+      </p:sp>
+      <p:pic>
+        <p:nvPicPr>
+          <p:cNvPr id="3" name="Image 0" descr="/home/claude/lecture/figs/toy_sim_vs_obs.png">
+            <a:extLst>
+              <a:ext uri="{FF2B5EF4-FFF2-40B4-BE49-F238E27FC236}">
+                <a16:creationId xmlns:a16="http://schemas.microsoft.com/office/drawing/2014/main" id="{1251786F-40C5-920E-1943-C4E687C24C19}"/>
+              </a:ext>
+            </a:extLst>
+          </p:cNvPr>
+          <p:cNvPicPr>
+            <a:picLocks noChangeAspect="1"/>
+          </p:cNvPicPr>
+          <p:nvPr/>
+        </p:nvPicPr>
+        <p:blipFill>
+          <a:blip r:embed="rId3"/>
+          <a:stretch>
+            <a:fillRect/>
+          </a:stretch>
+        </p:blipFill>
+        <p:spPr>
+          <a:xfrm>
+            <a:off x="5394960" y="1188720"/>
+            <a:ext cx="6263640" cy="4169664"/>
+          </a:xfrm>
+          <a:prstGeom prst="rect">
+            <a:avLst/>
+          </a:prstGeom>
+        </p:spPr>
+      </p:pic>
+      <p:sp>
+        <p:nvSpPr>
+          <p:cNvPr id="4" name="Text 1">
+            <a:extLst>
+              <a:ext uri="{FF2B5EF4-FFF2-40B4-BE49-F238E27FC236}">
+                <a16:creationId xmlns:a16="http://schemas.microsoft.com/office/drawing/2014/main" id="{304D1B78-B6FF-0F65-C2FC-02F5BEF59430}"/>
+              </a:ext>
+            </a:extLst>
+          </p:cNvPr>
+          <p:cNvSpPr/>
+          <p:nvPr/>
+        </p:nvSpPr>
+        <p:spPr>
+          <a:xfrm>
+            <a:off x="566928" y="1600200"/>
+            <a:ext cx="4572000" cy="1920240"/>
+          </a:xfrm>
+          <a:prstGeom prst="rect">
+            <a:avLst/>
+          </a:prstGeom>
+          <a:noFill/>
+          <a:ln/>
+        </p:spPr>
+        <p:txBody>
+          <a:bodyPr wrap="square" lIns="0" tIns="0" rIns="0" bIns="0" rtlCol="0" anchor="t"/>
+          <a:lstStyle/>
+          <a:p>
+            <a:pPr marL="0" indent="0">
+              <a:lnSpc>
+                <a:spcPts val="3400"/>
+              </a:lnSpc>
+              <a:buNone/>
+            </a:pPr>
+            <a:r>
+              <a:rPr lang="en-US" sz="2400" dirty="0">
+                <a:solidFill>
+                  <a:srgbClr val="000000"/>
+                </a:solidFill>
+                <a:latin typeface="Palatino" pitchFamily="34" charset="0"/>
+                <a:ea typeface="Palatino" pitchFamily="34" charset="-122"/>
+                <a:cs typeface="Palatino" pitchFamily="34" charset="-120"/>
+              </a:rPr>
+              <a:t>Three of these four panels were generated by the fitted model B. One is the real 80 students.</a:t>
+            </a:r>
+            <a:endParaRPr lang="en-US" sz="2400" dirty="0"/>
+          </a:p>
+        </p:txBody>
+      </p:sp>
+      <p:sp>
+        <p:nvSpPr>
+          <p:cNvPr id="5" name="Text 2">
+            <a:extLst>
+              <a:ext uri="{FF2B5EF4-FFF2-40B4-BE49-F238E27FC236}">
+                <a16:creationId xmlns:a16="http://schemas.microsoft.com/office/drawing/2014/main" id="{5AC1C0AF-CE6A-2D9B-5352-28611BAA9805}"/>
+              </a:ext>
+            </a:extLst>
+          </p:cNvPr>
+          <p:cNvSpPr/>
+          <p:nvPr/>
+        </p:nvSpPr>
+        <p:spPr>
+          <a:xfrm>
+            <a:off x="566928" y="3611880"/>
+            <a:ext cx="4572000" cy="548640"/>
+          </a:xfrm>
+          <a:prstGeom prst="rect">
+            <a:avLst/>
+          </a:prstGeom>
+          <a:noFill/>
+          <a:ln/>
+        </p:spPr>
+        <p:txBody>
+          <a:bodyPr wrap="square" lIns="0" tIns="0" rIns="0" bIns="0" rtlCol="0" anchor="t"/>
+          <a:lstStyle/>
+          <a:p>
+            <a:pPr marL="0" indent="0">
+              <a:buNone/>
+            </a:pPr>
+            <a:r>
+              <a:rPr lang="en-US" sz="2800" i="1" dirty="0">
+                <a:solidFill>
+                  <a:srgbClr val="000000"/>
+                </a:solidFill>
+                <a:latin typeface="Palatino" pitchFamily="34" charset="0"/>
+                <a:ea typeface="Palatino" pitchFamily="34" charset="-122"/>
+                <a:cs typeface="Palatino" pitchFamily="34" charset="-120"/>
+              </a:rPr>
+              <a:t>Which one is real?</a:t>
+            </a:r>
+            <a:endParaRPr lang="en-US" sz="2800" dirty="0"/>
+          </a:p>
+        </p:txBody>
+      </p:sp>
+      <p:sp>
+        <p:nvSpPr>
+          <p:cNvPr id="6" name="Text 3">
+            <a:extLst>
+              <a:ext uri="{FF2B5EF4-FFF2-40B4-BE49-F238E27FC236}">
+                <a16:creationId xmlns:a16="http://schemas.microsoft.com/office/drawing/2014/main" id="{22980604-8B25-AF01-0F00-F202BB7DAF61}"/>
+              </a:ext>
+            </a:extLst>
+          </p:cNvPr>
+          <p:cNvSpPr/>
+          <p:nvPr/>
+        </p:nvSpPr>
+        <p:spPr>
+          <a:xfrm>
+            <a:off x="566928" y="4434840"/>
+            <a:ext cx="4572000" cy="1920240"/>
+          </a:xfrm>
+          <a:prstGeom prst="rect">
+            <a:avLst/>
+          </a:prstGeom>
+          <a:noFill/>
+          <a:ln/>
+        </p:spPr>
+        <p:txBody>
+          <a:bodyPr wrap="square" lIns="0" tIns="0" rIns="0" bIns="0" rtlCol="0" anchor="t"/>
+          <a:lstStyle/>
+          <a:p>
+            <a:pPr marL="0" indent="0">
+              <a:lnSpc>
+                <a:spcPts val="3000"/>
+              </a:lnSpc>
+              <a:buNone/>
+            </a:pPr>
+            <a:r>
+              <a:rPr lang="en-US" sz="2100" dirty="0">
+                <a:solidFill>
+                  <a:srgbClr val="555555"/>
+                </a:solidFill>
+                <a:latin typeface="Palatino" pitchFamily="34" charset="0"/>
+                <a:ea typeface="Palatino" pitchFamily="34" charset="-122"/>
+                <a:cs typeface="Palatino" pitchFamily="34" charset="-120"/>
+              </a:rPr>
+              <a:t>Panel C. In the real data the small-footed students sit tightly around the line and the large-footed ones scatter widely.</a:t>
+            </a:r>
+            <a:endParaRPr lang="en-US" sz="2100" dirty="0"/>
+          </a:p>
+        </p:txBody>
+      </p:sp>
+    </p:spTree>
+    <p:extLst>
+      <p:ext uri="{BB962C8B-B14F-4D97-AF65-F5344CB8AC3E}">
+        <p14:creationId xmlns:p14="http://schemas.microsoft.com/office/powerpoint/2010/main" val="3098694461"/>
+      </p:ext>
+    </p:extLst>
+  </p:cSld>
+  <p:clrMapOvr>
+    <a:masterClrMapping/>
+  </p:clrMapOvr>
+</p:sld>
+</file>
+
+<file path=ppt/slides/slide11.xml><?xml version="1.0" encoding="utf-8"?>
+<p:sld xmlns:a="http://schemas.openxmlformats.org/drawingml/2006/main" xmlns:r="http://schemas.openxmlformats.org/officeDocument/2006/relationships" xmlns:p="http://schemas.openxmlformats.org/presentationml/2006/main">
   <p:cSld name="Slide 10">
     <p:bg>
       <p:bgPr>
@@ -2073,7 +2437,7 @@
 </p:sld>
 </file>
 
-<file path=ppt/slides/slide11.xml><?xml version="1.0" encoding="utf-8"?>
+<file path=ppt/slides/slide12.xml><?xml version="1.0" encoding="utf-8"?>
 <p:sld xmlns:a="http://schemas.openxmlformats.org/drawingml/2006/main" xmlns:r="http://schemas.openxmlformats.org/officeDocument/2006/relationships" xmlns:p="http://schemas.openxmlformats.org/presentationml/2006/main">
   <p:cSld name="Slide 11">
     <p:bg>
@@ -2145,7 +2509,7 @@
 </p:sld>
 </file>
 
-<file path=ppt/slides/slide12.xml><?xml version="1.0" encoding="utf-8"?>
+<file path=ppt/slides/slide13.xml><?xml version="1.0" encoding="utf-8"?>
 <p:sld xmlns:a="http://schemas.openxmlformats.org/drawingml/2006/main" xmlns:r="http://schemas.openxmlformats.org/officeDocument/2006/relationships" xmlns:p="http://schemas.openxmlformats.org/presentationml/2006/main">
   <p:cSld name="Slide 12">
     <p:bg>
@@ -2326,7 +2690,7 @@
 </p:sld>
 </file>
 
-<file path=ppt/slides/slide13.xml><?xml version="1.0" encoding="utf-8"?>
+<file path=ppt/slides/slide14.xml><?xml version="1.0" encoding="utf-8"?>
 <p:sld xmlns:a="http://schemas.openxmlformats.org/drawingml/2006/main" xmlns:r="http://schemas.openxmlformats.org/officeDocument/2006/relationships" xmlns:p="http://schemas.openxmlformats.org/presentationml/2006/main">
   <p:cSld name="Slide 13">
     <p:bg>
@@ -2585,7 +2949,7 @@
 </p:sld>
 </file>
 
-<file path=ppt/slides/slide14.xml><?xml version="1.0" encoding="utf-8"?>
+<file path=ppt/slides/slide15.xml><?xml version="1.0" encoding="utf-8"?>
 <p:sld xmlns:a="http://schemas.openxmlformats.org/drawingml/2006/main" xmlns:r="http://schemas.openxmlformats.org/officeDocument/2006/relationships" xmlns:p="http://schemas.openxmlformats.org/presentationml/2006/main">
   <p:cSld name="Slide 17">
     <p:bg>
@@ -5247,48 +5611,6 @@
               <a:t>Which one is real?</a:t>
             </a:r>
             <a:endParaRPr lang="en-US" sz="2800" dirty="0"/>
-          </a:p>
-        </p:txBody>
-      </p:sp>
-      <p:sp>
-        <p:nvSpPr>
-          <p:cNvPr id="6" name="Text 3"/>
-          <p:cNvSpPr/>
-          <p:nvPr/>
-        </p:nvSpPr>
-        <p:spPr>
-          <a:xfrm>
-            <a:off x="566928" y="4434840"/>
-            <a:ext cx="4572000" cy="1920240"/>
-          </a:xfrm>
-          <a:prstGeom prst="rect">
-            <a:avLst/>
-          </a:prstGeom>
-          <a:noFill/>
-          <a:ln/>
-        </p:spPr>
-        <p:txBody>
-          <a:bodyPr wrap="square" lIns="0" tIns="0" rIns="0" bIns="0" rtlCol="0" anchor="t"/>
-          <a:lstStyle/>
-          <a:p>
-            <a:pPr marL="0" indent="0">
-              <a:lnSpc>
-                <a:spcPts val="3000"/>
-              </a:lnSpc>
-              <a:buNone/>
-            </a:pPr>
-            <a:r>
-              <a:rPr lang="en-US" sz="2100" dirty="0">
-                <a:solidFill>
-                  <a:srgbClr val="555555"/>
-                </a:solidFill>
-                <a:latin typeface="Palatino" pitchFamily="34" charset="0"/>
-                <a:ea typeface="Palatino" pitchFamily="34" charset="-122"/>
-                <a:cs typeface="Palatino" pitchFamily="34" charset="-120"/>
-              </a:rPr>
-              <a:t>Panel C. In the real data the small-footed students sit tightly around the line and the large-footed ones scatter widely.</a:t>
-            </a:r>
-            <a:endParaRPr lang="en-US" sz="2100" dirty="0"/>
           </a:p>
         </p:txBody>
       </p:sp>

</xml_diff>